<commit_message>
Fix recording clock sync and publish corrected main demo
</commit_message>
<xml_diff>
--- a/docs/presentation/DanceCraft_Final_Presentation.pptx
+++ b/docs/presentation/DanceCraft_Final_Presentation.pptx
@@ -2,18 +2,18 @@
 <file path=ppt/presentation.xml><?xml version="1.0" encoding="utf-8"?>
 <p:presentation xmlns:p="http://schemas.openxmlformats.org/presentationml/2006/main">
   <p:sldMasterIdLst>
-    <p:sldMasterId xmlns:r="http://schemas.openxmlformats.org/officeDocument/2006/relationships" id="2147483648" r:id="R571c060d336c4f5e"/>
+    <p:sldMasterId xmlns:r="http://schemas.openxmlformats.org/officeDocument/2006/relationships" id="2147483648" r:id="R3aec761687934acf"/>
   </p:sldMasterIdLst>
   <p:notesMasterIdLst>
-    <p:notesMasterId xmlns:r="http://schemas.openxmlformats.org/officeDocument/2006/relationships" r:id="R55420f9956dd4440"/>
+    <p:notesMasterId xmlns:r="http://schemas.openxmlformats.org/officeDocument/2006/relationships" r:id="R0bd362cb76cf4b6d"/>
   </p:notesMasterIdLst>
   <p:sldIdLst>
-    <p:sldId xmlns:r="http://schemas.openxmlformats.org/officeDocument/2006/relationships" id="256" r:id="R95e7a244ecea4484"/>
-    <p:sldId xmlns:r="http://schemas.openxmlformats.org/officeDocument/2006/relationships" id="257" r:id="Re8eb708675a84f64"/>
-    <p:sldId xmlns:r="http://schemas.openxmlformats.org/officeDocument/2006/relationships" id="258" r:id="Rc206209c8cd0490e"/>
-    <p:sldId xmlns:r="http://schemas.openxmlformats.org/officeDocument/2006/relationships" id="259" r:id="R5f43b34adb1a45a4"/>
-    <p:sldId xmlns:r="http://schemas.openxmlformats.org/officeDocument/2006/relationships" id="260" r:id="R01ebf7eb607d4f4e"/>
-    <p:sldId xmlns:r="http://schemas.openxmlformats.org/officeDocument/2006/relationships" id="261" r:id="Rfe7e62c1cc7f4906"/>
+    <p:sldId xmlns:r="http://schemas.openxmlformats.org/officeDocument/2006/relationships" id="256" r:id="Rc0aa2e48006b45da"/>
+    <p:sldId xmlns:r="http://schemas.openxmlformats.org/officeDocument/2006/relationships" id="257" r:id="R43e73ab7f6374fa1"/>
+    <p:sldId xmlns:r="http://schemas.openxmlformats.org/officeDocument/2006/relationships" id="258" r:id="Rd93eb67e8fda4d83"/>
+    <p:sldId xmlns:r="http://schemas.openxmlformats.org/officeDocument/2006/relationships" id="259" r:id="R9e1f4ab298dc4e87"/>
+    <p:sldId xmlns:r="http://schemas.openxmlformats.org/officeDocument/2006/relationships" id="260" r:id="Ra193ad5bcdd748e5"/>
+    <p:sldId xmlns:r="http://schemas.openxmlformats.org/officeDocument/2006/relationships" id="261" r:id="R4efa8a10602f4465"/>
   </p:sldIdLst>
   <p:sldSz cx="12192000" cy="6858000"/>
   <p:notesSz cx="6858000" cy="9144000"/>
@@ -940,7 +940,7 @@
           </a:p>
           <a:p xmlns:a="http://schemas.openxmlformats.org/drawingml/2006/main">
             <a:r>
-              <a:t>Open DanceCraft_04_Synced_With_Audio.mp4 from the delivered video folder. Play approximately 25-30 seconds, then return to the app's saved result. Show the timestamped replay and the separate player and reference skeleton exports. Explain how the player can inspect a difficult move, practice the selected section, then retry against the host score. If the live app is unavailable, the saved video is the demo backup.</a:t>
+              <a:t>Open DanceCraft_04_Synced_With_Audio.mp4 from the DanceCraft_Videos_session12_v2 folder. Play approximately 25 seconds, then return to the app's saved result. Show the timestamped replay and the separate player and reference skeleton exports. Explain how the player can inspect a difficult move, practice the selected section, then retry against the host score. The saved video is the demo backup.</a:t>
             </a:r>
           </a:p>
           <a:p xmlns:a="http://schemas.openxmlformats.org/drawingml/2006/main">
@@ -951,7 +951,17 @@
           </a:p>
           <a:p xmlns:a="http://schemas.openxmlformats.org/drawingml/2006/main">
             <a:r>
-              <a:t>The poster is a frame from the user's latest saved history and synchronized video export. The export matches the song timeline using the recorded start marker, without changing the player's movement timing. The reference clip originates from the video registered by the user. Separate files: DanceCraft_01_Camera.mp4, DanceCraft_02_Camera_Skeleton.mp4, DanceCraft_03_Reference.mp4, DanceCraft_04_Synced_With_Audio.mp4, DanceCraft_05_Reference_Skeleton.mp4.</a:t>
+              <a:t>This poster comes from the corrected promotional export of the user's latest saved history. The legacy recording does not include the reference music clock. The export therefore applies a constant 1.30-second editorial alignment selected from motion cues. This is an editorial estimate, not a measurement of the original playback synchronization. The exporter maps camera PTS = reference time + 0.8294 seconds and uses the natural overlapping interval of approximately 29.83 seconds. It does not stretch movement or change stored scores. Future app recordings retain reference video-time anchors for synchronization.</a:t>
+            </a:r>
+          </a:p>
+          <a:p xmlns:a="http://schemas.openxmlformats.org/drawingml/2006/main">
+            <a:r>
+              <a:t/>
+            </a:r>
+          </a:p>
+          <a:p xmlns:a="http://schemas.openxmlformats.org/drawingml/2006/main">
+            <a:r>
+              <a:t>The reference clip originates from the video registered by the user. Separate files in the v2 folder: DanceCraft_01_Camera.mp4, DanceCraft_02_Camera_Skeleton.mp4, DanceCraft_03_Reference.mp4, DanceCraft_04_Synced_With_Audio.mp4, DanceCraft_05_Reference_Skeleton.mp4.</a:t>
             </a:r>
           </a:p>
         </p:txBody>
@@ -1276,8 +1286,8 @@
   </p:cSld>
   <p:clrMap bg1="lt1" tx1="dk1" bg2="lt2" tx2="dk2" accent1="accent1" accent2="accent2" accent3="accent3" accent4="accent4" accent5="accent5" accent6="accent6" hlink="hlink" folHlink="folHlink"/>
   <p:sldLayoutIdLst>
-    <p:sldLayoutId xmlns:r="http://schemas.openxmlformats.org/officeDocument/2006/relationships" id="2147483649" r:id="R7ab2aec83d344ff5"/>
-    <p:sldLayoutId xmlns:r="http://schemas.openxmlformats.org/officeDocument/2006/relationships" id="2147483650" r:id="R6a2e3900fb3845bc"/>
+    <p:sldLayoutId xmlns:r="http://schemas.openxmlformats.org/officeDocument/2006/relationships" id="2147483649" r:id="R7afd5a8ee18f4b91"/>
+    <p:sldLayoutId xmlns:r="http://schemas.openxmlformats.org/officeDocument/2006/relationships" id="2147483650" r:id="R6dff992ffdf049b7"/>
   </p:sldLayoutIdLst>
   <p:hf sldNum="0" hdr="0" ftr="0" dt="0"/>
   <p:txStyles>
@@ -2280,7 +2290,7 @@
           <p:cNvPr id="26" name="Image 0">
             <a:extLst xmlns:a="http://schemas.openxmlformats.org/drawingml/2006/main">
               <a:ext uri="{FF2B5EF4-FFF2-40B4-BE49-F238E27FC236}">
-                <a16:creationId xmlns:a16="http://schemas.microsoft.com/office/drawing/2014/main" id="{903D2873-C20A-49D0-87E2-AEF751DE5FB7}"/>
+                <a16:creationId xmlns:a16="http://schemas.microsoft.com/office/drawing/2014/main" id="{4894C0AC-3AAC-4A64-9711-626ED81AC340}"/>
               </a:ext>
             </a:extLst>
           </p:cNvPr>
@@ -2290,7 +2300,7 @@
           <p:nvPr/>
         </p:nvPicPr>
         <p:blipFill>
-          <a:blip xmlns:r="http://schemas.openxmlformats.org/officeDocument/2006/relationships" xmlns:a="http://schemas.openxmlformats.org/drawingml/2006/main" r:embed="R0017627728714f36"/>
+          <a:blip xmlns:r="http://schemas.openxmlformats.org/officeDocument/2006/relationships" xmlns:a="http://schemas.openxmlformats.org/drawingml/2006/main" r:embed="R145ff547d8f344af"/>
           <a:stretch xmlns:a="http://schemas.openxmlformats.org/drawingml/2006/main"/>
         </p:blipFill>
         <p:spPr>
@@ -2450,6 +2460,7 @@
           </a:lstStyle>
           <a:p xmlns:a="http://schemas.openxmlformats.org/drawingml/2006/main">
             <a:pPr algn="r">
+              <a:buNone/>
               <a:defRPr sz="900">
                 <a:solidFill>
                   <a:srgbClr val="ACB8D0"/>
@@ -3312,7 +3323,7 @@
           <p:cNvPr id="44" name="Image 0">
             <a:extLst xmlns:a="http://schemas.openxmlformats.org/drawingml/2006/main">
               <a:ext uri="{FF2B5EF4-FFF2-40B4-BE49-F238E27FC236}">
-                <a16:creationId xmlns:a16="http://schemas.microsoft.com/office/drawing/2014/main" id="{5386CD9D-DB91-4077-9328-161BC7D985E7}"/>
+                <a16:creationId xmlns:a16="http://schemas.microsoft.com/office/drawing/2014/main" id="{F4ABEF68-0C6D-4563-B268-6E540C19FCBB}"/>
               </a:ext>
             </a:extLst>
           </p:cNvPr>
@@ -3322,7 +3333,7 @@
           <p:nvPr/>
         </p:nvPicPr>
         <p:blipFill>
-          <a:blip xmlns:r="http://schemas.openxmlformats.org/officeDocument/2006/relationships" xmlns:a="http://schemas.openxmlformats.org/drawingml/2006/main" r:embed="Rb210b3f013fb4d55"/>
+          <a:blip xmlns:r="http://schemas.openxmlformats.org/officeDocument/2006/relationships" xmlns:a="http://schemas.openxmlformats.org/drawingml/2006/main" r:embed="Ra543896880ea4004"/>
           <a:stretch xmlns:a="http://schemas.openxmlformats.org/drawingml/2006/main"/>
         </p:blipFill>
         <p:spPr>
@@ -3389,7 +3400,7 @@
           <p:cNvPr id="46" name="Image 1">
             <a:extLst xmlns:a="http://schemas.openxmlformats.org/drawingml/2006/main">
               <a:ext uri="{FF2B5EF4-FFF2-40B4-BE49-F238E27FC236}">
-                <a16:creationId xmlns:a16="http://schemas.microsoft.com/office/drawing/2014/main" id="{DC297304-85E1-4B7C-A316-B910F902C9D2}"/>
+                <a16:creationId xmlns:a16="http://schemas.microsoft.com/office/drawing/2014/main" id="{B94E6337-5F53-4983-B520-37202A81F543}"/>
               </a:ext>
             </a:extLst>
           </p:cNvPr>
@@ -3399,7 +3410,7 @@
           <p:nvPr/>
         </p:nvPicPr>
         <p:blipFill>
-          <a:blip xmlns:r="http://schemas.openxmlformats.org/officeDocument/2006/relationships" xmlns:a="http://schemas.openxmlformats.org/drawingml/2006/main" r:embed="Rcf7eff46b493475f"/>
+          <a:blip xmlns:r="http://schemas.openxmlformats.org/officeDocument/2006/relationships" xmlns:a="http://schemas.openxmlformats.org/drawingml/2006/main" r:embed="Rbbe6785ee8e343eb"/>
           <a:stretch xmlns:a="http://schemas.openxmlformats.org/drawingml/2006/main">
             <a:fillRect l="0" t="0" r="0" b="0"/>
           </a:stretch>
@@ -3623,6 +3634,7 @@
           </a:lstStyle>
           <a:p xmlns:a="http://schemas.openxmlformats.org/drawingml/2006/main">
             <a:pPr>
+              <a:buNone/>
               <a:defRPr sz="900">
                 <a:solidFill>
                   <a:srgbClr val="7588A9"/>
@@ -3878,7 +3890,7 @@
           <p:cNvPr id="32" name="Image 0">
             <a:extLst xmlns:a="http://schemas.openxmlformats.org/drawingml/2006/main">
               <a:ext uri="{FF2B5EF4-FFF2-40B4-BE49-F238E27FC236}">
-                <a16:creationId xmlns:a16="http://schemas.microsoft.com/office/drawing/2014/main" id="{7DFFF0A9-B458-4FE5-B9E7-ACAE235CF0FC}"/>
+                <a16:creationId xmlns:a16="http://schemas.microsoft.com/office/drawing/2014/main" id="{5690B5D9-1EBB-4D72-8F50-026518EDA708}"/>
               </a:ext>
             </a:extLst>
           </p:cNvPr>
@@ -3888,7 +3900,7 @@
           <p:nvPr/>
         </p:nvPicPr>
         <p:blipFill>
-          <a:blip xmlns:r="http://schemas.openxmlformats.org/officeDocument/2006/relationships" xmlns:a="http://schemas.openxmlformats.org/drawingml/2006/main" r:embed="Rf7b823922a3e4429"/>
+          <a:blip xmlns:r="http://schemas.openxmlformats.org/officeDocument/2006/relationships" xmlns:a="http://schemas.openxmlformats.org/drawingml/2006/main" r:embed="Ra6213845c7304db4"/>
           <a:stretch xmlns:a="http://schemas.openxmlformats.org/drawingml/2006/main">
             <a:fillRect l="0" t="0" r="0" b="0"/>
           </a:stretch>
@@ -3957,7 +3969,7 @@
           <p:cNvPr id="34" name="Image 1">
             <a:extLst xmlns:a="http://schemas.openxmlformats.org/drawingml/2006/main">
               <a:ext uri="{FF2B5EF4-FFF2-40B4-BE49-F238E27FC236}">
-                <a16:creationId xmlns:a16="http://schemas.microsoft.com/office/drawing/2014/main" id="{23BD3860-1B19-458A-84EA-7991B6C64809}"/>
+                <a16:creationId xmlns:a16="http://schemas.microsoft.com/office/drawing/2014/main" id="{002DDC3C-BF40-4734-ADFD-50535616FD1D}"/>
               </a:ext>
             </a:extLst>
           </p:cNvPr>
@@ -3967,7 +3979,7 @@
           <p:nvPr/>
         </p:nvPicPr>
         <p:blipFill>
-          <a:blip xmlns:r="http://schemas.openxmlformats.org/officeDocument/2006/relationships" xmlns:a="http://schemas.openxmlformats.org/drawingml/2006/main" r:embed="Rd227ed3213b14240"/>
+          <a:blip xmlns:r="http://schemas.openxmlformats.org/officeDocument/2006/relationships" xmlns:a="http://schemas.openxmlformats.org/drawingml/2006/main" r:embed="R40acd31ce5d94814"/>
           <a:stretch xmlns:a="http://schemas.openxmlformats.org/drawingml/2006/main">
             <a:fillRect l="0" t="0" r="0" b="0"/>
           </a:stretch>
@@ -4513,6 +4525,7 @@
           </a:lstStyle>
           <a:p xmlns:a="http://schemas.openxmlformats.org/drawingml/2006/main">
             <a:pPr>
+              <a:buNone/>
               <a:defRPr sz="900">
                 <a:solidFill>
                   <a:srgbClr val="7588A9"/>
@@ -5218,7 +5231,7 @@
           <p:cNvPr id="39" name="Image 0">
             <a:extLst xmlns:a="http://schemas.openxmlformats.org/drawingml/2006/main">
               <a:ext uri="{FF2B5EF4-FFF2-40B4-BE49-F238E27FC236}">
-                <a16:creationId xmlns:a16="http://schemas.microsoft.com/office/drawing/2014/main" id="{BBAB2811-F18F-461A-A1CA-A215C19F07C6}"/>
+                <a16:creationId xmlns:a16="http://schemas.microsoft.com/office/drawing/2014/main" id="{27941CF6-B315-4B3A-A093-84D405C35859}"/>
               </a:ext>
             </a:extLst>
           </p:cNvPr>
@@ -5228,7 +5241,7 @@
           <p:nvPr/>
         </p:nvPicPr>
         <p:blipFill>
-          <a:blip xmlns:r="http://schemas.openxmlformats.org/officeDocument/2006/relationships" xmlns:a="http://schemas.openxmlformats.org/drawingml/2006/main" r:embed="R52d01b3fd8324062"/>
+          <a:blip xmlns:r="http://schemas.openxmlformats.org/officeDocument/2006/relationships" xmlns:a="http://schemas.openxmlformats.org/drawingml/2006/main" r:embed="R898516b8a34049f5"/>
           <a:stretch xmlns:a="http://schemas.openxmlformats.org/drawingml/2006/main"/>
         </p:blipFill>
         <p:spPr>
@@ -5341,7 +5354,7 @@
           <p:cNvPr id="42" name="Image 1">
             <a:extLst xmlns:a="http://schemas.openxmlformats.org/drawingml/2006/main">
               <a:ext uri="{FF2B5EF4-FFF2-40B4-BE49-F238E27FC236}">
-                <a16:creationId xmlns:a16="http://schemas.microsoft.com/office/drawing/2014/main" id="{2EC673E8-57CC-4BE8-AED1-78D025195EE9}"/>
+                <a16:creationId xmlns:a16="http://schemas.microsoft.com/office/drawing/2014/main" id="{B3B66CFA-3998-4116-8DB5-ECB2DEB75546}"/>
               </a:ext>
             </a:extLst>
           </p:cNvPr>
@@ -5351,7 +5364,7 @@
           <p:nvPr/>
         </p:nvPicPr>
         <p:blipFill>
-          <a:blip xmlns:r="http://schemas.openxmlformats.org/officeDocument/2006/relationships" xmlns:a="http://schemas.openxmlformats.org/drawingml/2006/main" r:embed="R51f05aa0ce394212"/>
+          <a:blip xmlns:r="http://schemas.openxmlformats.org/officeDocument/2006/relationships" xmlns:a="http://schemas.openxmlformats.org/drawingml/2006/main" r:embed="R166642f750ab4a44"/>
           <a:srcRect xmlns:a="http://schemas.openxmlformats.org/drawingml/2006/main" l="0" t="22481" r="0" b="22481"/>
           <a:stretch xmlns:a="http://schemas.openxmlformats.org/drawingml/2006/main"/>
         </p:blipFill>
@@ -5465,7 +5478,7 @@
           <p:cNvPr id="45" name="Image 2">
             <a:extLst xmlns:a="http://schemas.openxmlformats.org/drawingml/2006/main">
               <a:ext uri="{FF2B5EF4-FFF2-40B4-BE49-F238E27FC236}">
-                <a16:creationId xmlns:a16="http://schemas.microsoft.com/office/drawing/2014/main" id="{9812BFA7-940D-4B24-9AF3-FF90D3EEE5BC}"/>
+                <a16:creationId xmlns:a16="http://schemas.microsoft.com/office/drawing/2014/main" id="{36738CEB-454E-403C-9A0F-5D869FDFA05A}"/>
               </a:ext>
             </a:extLst>
           </p:cNvPr>
@@ -5475,7 +5488,7 @@
           <p:nvPr/>
         </p:nvPicPr>
         <p:blipFill>
-          <a:blip xmlns:r="http://schemas.openxmlformats.org/officeDocument/2006/relationships" xmlns:a="http://schemas.openxmlformats.org/drawingml/2006/main" r:embed="R8e2cac133e344f1a"/>
+          <a:blip xmlns:r="http://schemas.openxmlformats.org/officeDocument/2006/relationships" xmlns:a="http://schemas.openxmlformats.org/drawingml/2006/main" r:embed="R673873f61b77421f"/>
           <a:srcRect xmlns:a="http://schemas.openxmlformats.org/drawingml/2006/main" l="9837" t="0" r="9837" b="0"/>
           <a:stretch xmlns:a="http://schemas.openxmlformats.org/drawingml/2006/main"/>
         </p:blipFill>
@@ -5599,7 +5612,7 @@
           <p:cNvPr id="48" name="Image 3">
             <a:extLst xmlns:a="http://schemas.openxmlformats.org/drawingml/2006/main">
               <a:ext uri="{FF2B5EF4-FFF2-40B4-BE49-F238E27FC236}">
-                <a16:creationId xmlns:a16="http://schemas.microsoft.com/office/drawing/2014/main" id="{F937FCC7-E09C-4DA6-8391-1B3DE3893CC0}"/>
+                <a16:creationId xmlns:a16="http://schemas.microsoft.com/office/drawing/2014/main" id="{5142BB63-15EE-47ED-B832-E89C9007649E}"/>
               </a:ext>
             </a:extLst>
           </p:cNvPr>
@@ -5609,7 +5622,7 @@
           <p:nvPr/>
         </p:nvPicPr>
         <p:blipFill>
-          <a:blip xmlns:r="http://schemas.openxmlformats.org/officeDocument/2006/relationships" xmlns:a="http://schemas.openxmlformats.org/drawingml/2006/main" r:embed="R75f749c7829f4ffc"/>
+          <a:blip xmlns:r="http://schemas.openxmlformats.org/officeDocument/2006/relationships" xmlns:a="http://schemas.openxmlformats.org/drawingml/2006/main" r:embed="R4ad8d70e100f443e"/>
           <a:srcRect xmlns:a="http://schemas.openxmlformats.org/drawingml/2006/main" l="17846" t="0" r="17846" b="0"/>
           <a:stretch xmlns:a="http://schemas.openxmlformats.org/drawingml/2006/main"/>
         </p:blipFill>
@@ -5922,6 +5935,7 @@
           </a:lstStyle>
           <a:p xmlns:a="http://schemas.openxmlformats.org/drawingml/2006/main">
             <a:pPr>
+              <a:buNone/>
               <a:defRPr sz="1400">
                 <a:solidFill>
                   <a:srgbClr val="ACB8D0"/>
@@ -5940,7 +5954,7 @@
                 <a:ea typeface="Inter"/>
                 <a:cs typeface="Inter"/>
               </a:rPr>
-              <a:t>The latest saved attempt, with synchronized reference video and audio</a:t>
+              <a:t>Saved attempt with reference music and a fixed 1.30 s timing adjustment</a:t>
             </a:r>
           </a:p>
         </p:txBody>
@@ -5950,7 +5964,7 @@
           <p:cNvPr id="4" name="">
             <a:extLst xmlns:a="http://schemas.openxmlformats.org/drawingml/2006/main">
               <a:ext uri="{FF2B5EF4-FFF2-40B4-BE49-F238E27FC236}">
-                <a16:creationId xmlns:a16="http://schemas.microsoft.com/office/drawing/2014/main" id="{87886784-2FDF-4544-B067-CC5DD07D5909}"/>
+                <a16:creationId xmlns:a16="http://schemas.microsoft.com/office/drawing/2014/main" id="{394CFD3B-13E9-468C-9B98-AE151C06333A}"/>
               </a:ext>
             </a:extLst>
           </p:cNvPr>
@@ -5960,7 +5974,7 @@
           <p:nvPr/>
         </p:nvPicPr>
         <p:blipFill>
-          <a:blip xmlns:r="http://schemas.openxmlformats.org/officeDocument/2006/relationships" xmlns:a="http://schemas.openxmlformats.org/drawingml/2006/main" r:embed="R516d2a6830b04b56"/>
+          <a:blip xmlns:r="http://schemas.openxmlformats.org/officeDocument/2006/relationships" xmlns:a="http://schemas.openxmlformats.org/drawingml/2006/main" r:embed="R98a01d447e7148d2"/>
           <a:stretch xmlns:a="http://schemas.openxmlformats.org/drawingml/2006/main"/>
         </p:blipFill>
         <p:spPr>
@@ -6018,6 +6032,7 @@
           </a:lstStyle>
           <a:p xmlns:a="http://schemas.openxmlformats.org/drawingml/2006/main">
             <a:pPr>
+              <a:buNone/>
               <a:defRPr sz="2000" b="1">
                 <a:solidFill>
                   <a:srgbClr val="F5F7FF"/>
@@ -6086,6 +6101,7 @@
           </a:lstStyle>
           <a:p xmlns:a="http://schemas.openxmlformats.org/drawingml/2006/main">
             <a:pPr>
+              <a:buNone/>
               <a:defRPr sz="1500">
                 <a:solidFill>
                   <a:srgbClr val="ACB8D0"/>
@@ -6114,6 +6130,7 @@
           </a:p>
           <a:p xmlns:a="http://schemas.openxmlformats.org/drawingml/2006/main">
             <a:pPr>
+              <a:buNone/>
               <a:defRPr sz="1500">
                 <a:solidFill>
                   <a:srgbClr val="ACB8D0"/>
@@ -6182,6 +6199,7 @@
           </a:lstStyle>
           <a:p xmlns:a="http://schemas.openxmlformats.org/drawingml/2006/main">
             <a:pPr>
+              <a:buNone/>
               <a:defRPr sz="1800" b="1">
                 <a:solidFill>
                   <a:srgbClr val="48D7FA"/>
@@ -6250,6 +6268,7 @@
           </a:lstStyle>
           <a:p xmlns:a="http://schemas.openxmlformats.org/drawingml/2006/main">
             <a:pPr>
+              <a:buNone/>
               <a:defRPr sz="1050">
                 <a:solidFill>
                   <a:srgbClr val="7588A9"/>
@@ -6300,7 +6319,7 @@
           <p:cNvPr id="3" name="Picture 2">
             <a:extLst xmlns:a="http://schemas.openxmlformats.org/drawingml/2006/main">
               <a:ext uri="{FF2B5EF4-FFF2-40B4-BE49-F238E27FC236}">
-                <a16:creationId xmlns:a16="http://schemas.microsoft.com/office/drawing/2014/main" id="{3EBE2AB5-DEE7-4BF0-B492-FD0DEE29C59B}"/>
+                <a16:creationId xmlns:a16="http://schemas.microsoft.com/office/drawing/2014/main" id="{648BAE08-814E-432D-9F5B-D1C855330413}"/>
               </a:ext>
             </a:extLst>
           </p:cNvPr>
@@ -6310,7 +6329,7 @@
           <p:nvPr/>
         </p:nvPicPr>
         <p:blipFill>
-          <a:blip xmlns:r="http://schemas.openxmlformats.org/officeDocument/2006/relationships" xmlns:a="http://schemas.openxmlformats.org/drawingml/2006/main" r:embed="Re7644bf574d54d6d"/>
+          <a:blip xmlns:r="http://schemas.openxmlformats.org/officeDocument/2006/relationships" xmlns:a="http://schemas.openxmlformats.org/drawingml/2006/main" r:embed="R2423344d3ac8484c"/>
           <a:srcRect xmlns:a="http://schemas.openxmlformats.org/drawingml/2006/main" l="0" t="5879" r="0" b="6100"/>
           <a:stretch xmlns:a="http://schemas.openxmlformats.org/drawingml/2006/main">
             <a:fillRect l="0" t="0" r="0" b="0"/>
@@ -6331,7 +6350,7 @@
           <p:cNvPr id="5" name="Picture 4">
             <a:extLst xmlns:a="http://schemas.openxmlformats.org/drawingml/2006/main">
               <a:ext uri="{FF2B5EF4-FFF2-40B4-BE49-F238E27FC236}">
-                <a16:creationId xmlns:a16="http://schemas.microsoft.com/office/drawing/2014/main" id="{0E72B381-5FE0-40EE-AC08-C75250B5866B}"/>
+                <a16:creationId xmlns:a16="http://schemas.microsoft.com/office/drawing/2014/main" id="{C8669CDD-1ABE-411B-9BD7-55AA8F6A3ADA}"/>
               </a:ext>
             </a:extLst>
           </p:cNvPr>
@@ -6341,7 +6360,7 @@
           <p:nvPr/>
         </p:nvPicPr>
         <p:blipFill>
-          <a:blip xmlns:r="http://schemas.openxmlformats.org/officeDocument/2006/relationships" xmlns:a="http://schemas.openxmlformats.org/drawingml/2006/main" r:embed="Rabb845323ee84a1a"/>
+          <a:blip xmlns:r="http://schemas.openxmlformats.org/officeDocument/2006/relationships" xmlns:a="http://schemas.openxmlformats.org/drawingml/2006/main" r:embed="R0d5329f3625c4ccc"/>
           <a:stretch xmlns:a="http://schemas.openxmlformats.org/drawingml/2006/main">
             <a:fillRect l="0" t="0" r="0" b="0"/>
           </a:stretch>

</xml_diff>